<commit_message>
deliverables: final overhead tables (mpi3 paced wall) + pydarshan native/streamed HTML
- paper_overhead_tables.pptx: 5 workload slides, 4-row x 7-col (arm, events, send avg us,
  push avg us, init, finalize, walltime, overhead). MPI uses the paced PAPER_mpi3 run
  (valid ~600s wall); DLIO wall is cold/warm-dominated so per-event is the metric.
- deliverables/pydarshan_html/: native + streamed pydarshan reports. CXI workloads
  (io_bench, io_bench_py, python-ml) have BOTH; mpi/dlio have native only (streamed
  reconstructed logs have no HEATMAP module -> pydarshan can't render the heatmap panel).
- results/MPI_DLIO_DATA_STATUS.md: which 2-node runs have valid data + why dlio wall is noisy.
</commit_message>
<xml_diff>
--- a/deliverables/paper_overhead_tables.pptx
+++ b/deliverables/paper_overhead_tables.pptx
@@ -6541,7 +6541,7 @@
                 </a:solidFill>
                 <a:latin typeface="Segoe UI"/>
               </a:rPr>
-              <a:t>MPI unsupported over CXI. Fidelity EXACT (32-&gt;1 aggregated). Workload is I/O-trivial (0.34 s); per-event cost is the metric, wall n/a.</a:t>
+              <a:t>MPI unsupported over CXI. Paced (IO_SLEEP_MS) for a comparable ~600 s wall. Fidelity EXACT (32-&gt;1 aggregated).</a:t>
             </a:r>
           </a:p>
         </p:txBody>
@@ -6556,7 +6556,7 @@
         </p:nvGraphicFramePr>
         <p:xfrm>
           <a:off x="365760" y="2011680"/>
-          <a:ext cx="11429999" cy="3200400"/>
+          <a:ext cx="11429999" cy="1920239"/>
         </p:xfrm>
         <a:graphic>
           <a:graphicData uri="http://schemas.openxmlformats.org/drawingml/2006/table">
@@ -6574,7 +6574,7 @@
                 <a:gridCol w="1358537"/>
                 <a:gridCol w="1358537"/>
               </a:tblGrid>
-              <a:tr h="640080">
+              <a:tr h="640079">
                 <a:tc>
                   <a:txBody>
                     <a:bodyPr/>
@@ -6760,7 +6760,7 @@
                   </a:tcPr>
                 </a:tc>
               </a:tr>
-              <a:tr h="640080">
+              <a:tr h="640079">
                 <a:tc>
                   <a:txBody>
                     <a:bodyPr/>
@@ -6912,7 +6912,7 @@
                           </a:solidFill>
                           <a:latin typeface="Segoe UI"/>
                         </a:rPr>
-                        <a:t>0.34</a:t>
+                        <a:t>602.4</a:t>
                       </a:r>
                     </a:p>
                   </a:txBody>
@@ -6935,7 +6935,7 @@
                           </a:solidFill>
                           <a:latin typeface="Segoe UI"/>
                         </a:rPr>
-                        <a:t>n/a</a:t>
+                        <a:t>0.0</a:t>
                       </a:r>
                     </a:p>
                   </a:txBody>
@@ -6946,7 +6946,7 @@
                   </a:tcPr>
                 </a:tc>
               </a:tr>
-              <a:tr h="640080">
+              <a:tr h="640081">
                 <a:tc>
                   <a:txBody>
                     <a:bodyPr/>
@@ -6983,7 +6983,7 @@
                           </a:solidFill>
                           <a:latin typeface="Segoe UI"/>
                         </a:rPr>
-                        <a:t>26,566</a:t>
+                        <a:t>39,770</a:t>
                       </a:r>
                     </a:p>
                   </a:txBody>
@@ -7006,7 +7006,7 @@
                           </a:solidFill>
                           <a:latin typeface="Segoe UI"/>
                         </a:rPr>
-                        <a:t>7.32</a:t>
+                        <a:t>15.0</a:t>
                       </a:r>
                     </a:p>
                   </a:txBody>
@@ -7029,7 +7029,7 @@
                           </a:solidFill>
                           <a:latin typeface="Segoe UI"/>
                         </a:rPr>
-                        <a:t>35.09</a:t>
+                        <a:t>67.2</a:t>
                       </a:r>
                     </a:p>
                   </a:txBody>
@@ -7052,7 +7052,7 @@
                           </a:solidFill>
                           <a:latin typeface="Segoe UI"/>
                         </a:rPr>
-                        <a:t>3.05</a:t>
+                        <a:t>2.70</a:t>
                       </a:r>
                     </a:p>
                   </a:txBody>
@@ -7075,7 +7075,7 @@
                           </a:solidFill>
                           <a:latin typeface="Segoe UI"/>
                         </a:rPr>
-                        <a:t>1.14</a:t>
+                        <a:t>0.003</a:t>
                       </a:r>
                     </a:p>
                   </a:txBody>
@@ -7098,7 +7098,7 @@
                           </a:solidFill>
                           <a:latin typeface="Segoe UI"/>
                         </a:rPr>
-                        <a:t>0.34</a:t>
+                        <a:t>600.7</a:t>
                       </a:r>
                     </a:p>
                   </a:txBody>
@@ -7121,379 +7121,7 @@
                           </a:solidFill>
                           <a:latin typeface="Segoe UI"/>
                         </a:rPr>
-                        <a:t>n/a</a:t>
-                      </a:r>
-                    </a:p>
-                  </a:txBody>
-                  <a:tcPr marL="45720" marR="45720" marT="27432" marB="27432">
-                    <a:solidFill>
-                      <a:srgbClr val="1A222C"/>
-                    </a:solidFill>
-                  </a:tcPr>
-                </a:tc>
-              </a:tr>
-              <a:tr h="640080">
-                <a:tc>
-                  <a:txBody>
-                    <a:bodyPr/>
-                    <a:lstStyle/>
-                    <a:p>
-                      <a:pPr algn="l"/>
-                      <a:r>
-                        <a:rPr sz="1400" b="0">
-                          <a:solidFill>
-                            <a:srgbClr val="4FC3F7"/>
-                          </a:solidFill>
-                          <a:latin typeface="Segoe UI"/>
-                        </a:rPr>
-                        <a:t>streaming r2</a:t>
-                      </a:r>
-                    </a:p>
-                  </a:txBody>
-                  <a:tcPr marL="45720" marR="45720" marT="27432" marB="27432">
-                    <a:solidFill>
-                      <a:srgbClr val="1A222C"/>
-                    </a:solidFill>
-                  </a:tcPr>
-                </a:tc>
-                <a:tc>
-                  <a:txBody>
-                    <a:bodyPr/>
-                    <a:lstStyle/>
-                    <a:p>
-                      <a:pPr algn="ctr"/>
-                      <a:r>
-                        <a:rPr sz="1400" b="0">
-                          <a:solidFill>
-                            <a:srgbClr val="E8EDF2"/>
-                          </a:solidFill>
-                          <a:latin typeface="Segoe UI"/>
-                        </a:rPr>
-                        <a:t>26,566</a:t>
-                      </a:r>
-                    </a:p>
-                  </a:txBody>
-                  <a:tcPr marL="45720" marR="45720" marT="27432" marB="27432">
-                    <a:solidFill>
-                      <a:srgbClr val="1A222C"/>
-                    </a:solidFill>
-                  </a:tcPr>
-                </a:tc>
-                <a:tc>
-                  <a:txBody>
-                    <a:bodyPr/>
-                    <a:lstStyle/>
-                    <a:p>
-                      <a:pPr algn="ctr"/>
-                      <a:r>
-                        <a:rPr sz="1400" b="0">
-                          <a:solidFill>
-                            <a:srgbClr val="E8EDF2"/>
-                          </a:solidFill>
-                          <a:latin typeface="Segoe UI"/>
-                        </a:rPr>
-                        <a:t>11.95</a:t>
-                      </a:r>
-                    </a:p>
-                  </a:txBody>
-                  <a:tcPr marL="45720" marR="45720" marT="27432" marB="27432">
-                    <a:solidFill>
-                      <a:srgbClr val="1A222C"/>
-                    </a:solidFill>
-                  </a:tcPr>
-                </a:tc>
-                <a:tc>
-                  <a:txBody>
-                    <a:bodyPr/>
-                    <a:lstStyle/>
-                    <a:p>
-                      <a:pPr algn="ctr"/>
-                      <a:r>
-                        <a:rPr sz="1400" b="0">
-                          <a:solidFill>
-                            <a:srgbClr val="E8EDF2"/>
-                          </a:solidFill>
-                          <a:latin typeface="Segoe UI"/>
-                        </a:rPr>
-                        <a:t>32.73</a:t>
-                      </a:r>
-                    </a:p>
-                  </a:txBody>
-                  <a:tcPr marL="45720" marR="45720" marT="27432" marB="27432">
-                    <a:solidFill>
-                      <a:srgbClr val="1A222C"/>
-                    </a:solidFill>
-                  </a:tcPr>
-                </a:tc>
-                <a:tc>
-                  <a:txBody>
-                    <a:bodyPr/>
-                    <a:lstStyle/>
-                    <a:p>
-                      <a:pPr algn="ctr"/>
-                      <a:r>
-                        <a:rPr sz="1400" b="0">
-                          <a:solidFill>
-                            <a:srgbClr val="E8EDF2"/>
-                          </a:solidFill>
-                          <a:latin typeface="Segoe UI"/>
-                        </a:rPr>
-                        <a:t>46.3</a:t>
-                      </a:r>
-                    </a:p>
-                  </a:txBody>
-                  <a:tcPr marL="45720" marR="45720" marT="27432" marB="27432">
-                    <a:solidFill>
-                      <a:srgbClr val="1A222C"/>
-                    </a:solidFill>
-                  </a:tcPr>
-                </a:tc>
-                <a:tc>
-                  <a:txBody>
-                    <a:bodyPr/>
-                    <a:lstStyle/>
-                    <a:p>
-                      <a:pPr algn="ctr"/>
-                      <a:r>
-                        <a:rPr sz="1400" b="0">
-                          <a:solidFill>
-                            <a:srgbClr val="E8EDF2"/>
-                          </a:solidFill>
-                          <a:latin typeface="Segoe UI"/>
-                        </a:rPr>
-                        <a:t>0.37</a:t>
-                      </a:r>
-                    </a:p>
-                  </a:txBody>
-                  <a:tcPr marL="45720" marR="45720" marT="27432" marB="27432">
-                    <a:solidFill>
-                      <a:srgbClr val="1A222C"/>
-                    </a:solidFill>
-                  </a:tcPr>
-                </a:tc>
-                <a:tc>
-                  <a:txBody>
-                    <a:bodyPr/>
-                    <a:lstStyle/>
-                    <a:p>
-                      <a:pPr algn="ctr"/>
-                      <a:r>
-                        <a:rPr sz="1400" b="0">
-                          <a:solidFill>
-                            <a:srgbClr val="E8EDF2"/>
-                          </a:solidFill>
-                          <a:latin typeface="Segoe UI"/>
-                        </a:rPr>
-                        <a:t>0.34</a:t>
-                      </a:r>
-                    </a:p>
-                  </a:txBody>
-                  <a:tcPr marL="45720" marR="45720" marT="27432" marB="27432">
-                    <a:solidFill>
-                      <a:srgbClr val="1A222C"/>
-                    </a:solidFill>
-                  </a:tcPr>
-                </a:tc>
-                <a:tc>
-                  <a:txBody>
-                    <a:bodyPr/>
-                    <a:lstStyle/>
-                    <a:p>
-                      <a:pPr algn="ctr"/>
-                      <a:r>
-                        <a:rPr sz="1400" b="0">
-                          <a:solidFill>
-                            <a:srgbClr val="E8EDF2"/>
-                          </a:solidFill>
-                          <a:latin typeface="Segoe UI"/>
-                        </a:rPr>
-                        <a:t>n/a</a:t>
-                      </a:r>
-                    </a:p>
-                  </a:txBody>
-                  <a:tcPr marL="45720" marR="45720" marT="27432" marB="27432">
-                    <a:solidFill>
-                      <a:srgbClr val="1A222C"/>
-                    </a:solidFill>
-                  </a:tcPr>
-                </a:tc>
-              </a:tr>
-              <a:tr h="640080">
-                <a:tc>
-                  <a:txBody>
-                    <a:bodyPr/>
-                    <a:lstStyle/>
-                    <a:p>
-                      <a:pPr algn="l"/>
-                      <a:r>
-                        <a:rPr sz="1400" b="0">
-                          <a:solidFill>
-                            <a:srgbClr val="4FC3F7"/>
-                          </a:solidFill>
-                          <a:latin typeface="Segoe UI"/>
-                        </a:rPr>
-                        <a:t>streaming r3</a:t>
-                      </a:r>
-                    </a:p>
-                  </a:txBody>
-                  <a:tcPr marL="45720" marR="45720" marT="27432" marB="27432">
-                    <a:solidFill>
-                      <a:srgbClr val="1A222C"/>
-                    </a:solidFill>
-                  </a:tcPr>
-                </a:tc>
-                <a:tc>
-                  <a:txBody>
-                    <a:bodyPr/>
-                    <a:lstStyle/>
-                    <a:p>
-                      <a:pPr algn="ctr"/>
-                      <a:r>
-                        <a:rPr sz="1400" b="0">
-                          <a:solidFill>
-                            <a:srgbClr val="E8EDF2"/>
-                          </a:solidFill>
-                          <a:latin typeface="Segoe UI"/>
-                        </a:rPr>
-                        <a:t>26,566</a:t>
-                      </a:r>
-                    </a:p>
-                  </a:txBody>
-                  <a:tcPr marL="45720" marR="45720" marT="27432" marB="27432">
-                    <a:solidFill>
-                      <a:srgbClr val="1A222C"/>
-                    </a:solidFill>
-                  </a:tcPr>
-                </a:tc>
-                <a:tc>
-                  <a:txBody>
-                    <a:bodyPr/>
-                    <a:lstStyle/>
-                    <a:p>
-                      <a:pPr algn="ctr"/>
-                      <a:r>
-                        <a:rPr sz="1400" b="0">
-                          <a:solidFill>
-                            <a:srgbClr val="E8EDF2"/>
-                          </a:solidFill>
-                          <a:latin typeface="Segoe UI"/>
-                        </a:rPr>
-                        <a:t>15.74</a:t>
-                      </a:r>
-                    </a:p>
-                  </a:txBody>
-                  <a:tcPr marL="45720" marR="45720" marT="27432" marB="27432">
-                    <a:solidFill>
-                      <a:srgbClr val="1A222C"/>
-                    </a:solidFill>
-                  </a:tcPr>
-                </a:tc>
-                <a:tc>
-                  <a:txBody>
-                    <a:bodyPr/>
-                    <a:lstStyle/>
-                    <a:p>
-                      <a:pPr algn="ctr"/>
-                      <a:r>
-                        <a:rPr sz="1400" b="0">
-                          <a:solidFill>
-                            <a:srgbClr val="E8EDF2"/>
-                          </a:solidFill>
-                          <a:latin typeface="Segoe UI"/>
-                        </a:rPr>
-                        <a:t>35.21</a:t>
-                      </a:r>
-                    </a:p>
-                  </a:txBody>
-                  <a:tcPr marL="45720" marR="45720" marT="27432" marB="27432">
-                    <a:solidFill>
-                      <a:srgbClr val="1A222C"/>
-                    </a:solidFill>
-                  </a:tcPr>
-                </a:tc>
-                <a:tc>
-                  <a:txBody>
-                    <a:bodyPr/>
-                    <a:lstStyle/>
-                    <a:p>
-                      <a:pPr algn="ctr"/>
-                      <a:r>
-                        <a:rPr sz="1400" b="0">
-                          <a:solidFill>
-                            <a:srgbClr val="E8EDF2"/>
-                          </a:solidFill>
-                          <a:latin typeface="Segoe UI"/>
-                        </a:rPr>
-                        <a:t>3.86</a:t>
-                      </a:r>
-                    </a:p>
-                  </a:txBody>
-                  <a:tcPr marL="45720" marR="45720" marT="27432" marB="27432">
-                    <a:solidFill>
-                      <a:srgbClr val="1A222C"/>
-                    </a:solidFill>
-                  </a:tcPr>
-                </a:tc>
-                <a:tc>
-                  <a:txBody>
-                    <a:bodyPr/>
-                    <a:lstStyle/>
-                    <a:p>
-                      <a:pPr algn="ctr"/>
-                      <a:r>
-                        <a:rPr sz="1400" b="0">
-                          <a:solidFill>
-                            <a:srgbClr val="E8EDF2"/>
-                          </a:solidFill>
-                          <a:latin typeface="Segoe UI"/>
-                        </a:rPr>
-                        <a:t>0.004</a:t>
-                      </a:r>
-                    </a:p>
-                  </a:txBody>
-                  <a:tcPr marL="45720" marR="45720" marT="27432" marB="27432">
-                    <a:solidFill>
-                      <a:srgbClr val="1A222C"/>
-                    </a:solidFill>
-                  </a:tcPr>
-                </a:tc>
-                <a:tc>
-                  <a:txBody>
-                    <a:bodyPr/>
-                    <a:lstStyle/>
-                    <a:p>
-                      <a:pPr algn="ctr"/>
-                      <a:r>
-                        <a:rPr sz="1400" b="0">
-                          <a:solidFill>
-                            <a:srgbClr val="E8EDF2"/>
-                          </a:solidFill>
-                          <a:latin typeface="Segoe UI"/>
-                        </a:rPr>
-                        <a:t>0.34</a:t>
-                      </a:r>
-                    </a:p>
-                  </a:txBody>
-                  <a:tcPr marL="45720" marR="45720" marT="27432" marB="27432">
-                    <a:solidFill>
-                      <a:srgbClr val="1A222C"/>
-                    </a:solidFill>
-                  </a:tcPr>
-                </a:tc>
-                <a:tc>
-                  <a:txBody>
-                    <a:bodyPr/>
-                    <a:lstStyle/>
-                    <a:p>
-                      <a:pPr algn="ctr"/>
-                      <a:r>
-                        <a:rPr sz="1400" b="0">
-                          <a:solidFill>
-                            <a:srgbClr val="E8EDF2"/>
-                          </a:solidFill>
-                          <a:latin typeface="Segoe UI"/>
-                        </a:rPr>
-                        <a:t>n/a</a:t>
+                        <a:t>-1.7</a:t>
                       </a:r>
                     </a:p>
                   </a:txBody>
@@ -7634,7 +7262,7 @@
                 </a:solidFill>
                 <a:latin typeface="Segoe UI"/>
               </a:rPr>
-              <a:t>TensorFlow NPZ data-gen. Fidelity EXACT (32-&gt;1 aggregated). Per-event cost is the metric.</a:t>
+              <a:t>TensorFlow NPZ data-gen. Fidelity EXACT (32-&gt;1 aggregated). Wall = cold/warm-dominated -&gt; per-event cost is the metric.</a:t>
             </a:r>
           </a:p>
         </p:txBody>
@@ -7649,7 +7277,7 @@
         </p:nvGraphicFramePr>
         <p:xfrm>
           <a:off x="365760" y="2011680"/>
-          <a:ext cx="11429999" cy="3200400"/>
+          <a:ext cx="11429999" cy="2560320"/>
         </p:xfrm>
         <a:graphic>
           <a:graphicData uri="http://schemas.openxmlformats.org/drawingml/2006/table">
@@ -8099,7 +7727,7 @@
                           </a:solidFill>
                           <a:latin typeface="Segoe UI"/>
                         </a:rPr>
-                        <a:t>3.00</a:t>
+                        <a:t>3.0</a:t>
                       </a:r>
                     </a:p>
                   </a:txBody>
@@ -8122,7 +7750,7 @@
                           </a:solidFill>
                           <a:latin typeface="Segoe UI"/>
                         </a:rPr>
-                        <a:t>37.96</a:t>
+                        <a:t>38.0</a:t>
                       </a:r>
                     </a:p>
                   </a:txBody>
@@ -8285,7 +7913,7 @@
                           </a:solidFill>
                           <a:latin typeface="Segoe UI"/>
                         </a:rPr>
-                        <a:t>4.62</a:t>
+                        <a:t>4.6</a:t>
                       </a:r>
                     </a:p>
                   </a:txBody>
@@ -8308,7 +7936,7 @@
                           </a:solidFill>
                           <a:latin typeface="Segoe UI"/>
                         </a:rPr>
-                        <a:t>42.54</a:t>
+                        <a:t>42.5</a:t>
                       </a:r>
                     </a:p>
                   </a:txBody>
@@ -8331,7 +7959,7 @@
                           </a:solidFill>
                           <a:latin typeface="Segoe UI"/>
                         </a:rPr>
-                        <a:t>4.10</a:t>
+                        <a:t>4.09</a:t>
                       </a:r>
                     </a:p>
                   </a:txBody>
@@ -8401,192 +8029,6 @@
                           <a:latin typeface="Segoe UI"/>
                         </a:rPr>
                         <a:t>n/a</a:t>
-                      </a:r>
-                    </a:p>
-                  </a:txBody>
-                  <a:tcPr marL="45720" marR="45720" marT="27432" marB="27432">
-                    <a:solidFill>
-                      <a:srgbClr val="1A222C"/>
-                    </a:solidFill>
-                  </a:tcPr>
-                </a:tc>
-              </a:tr>
-              <a:tr h="640080">
-                <a:tc>
-                  <a:txBody>
-                    <a:bodyPr/>
-                    <a:lstStyle/>
-                    <a:p>
-                      <a:pPr algn="l"/>
-                      <a:r>
-                        <a:rPr sz="1400" b="0">
-                          <a:solidFill>
-                            <a:srgbClr val="4FC3F7"/>
-                          </a:solidFill>
-                          <a:latin typeface="Segoe UI"/>
-                        </a:rPr>
-                        <a:t>streaming r3</a:t>
-                      </a:r>
-                    </a:p>
-                  </a:txBody>
-                  <a:tcPr marL="45720" marR="45720" marT="27432" marB="27432">
-                    <a:solidFill>
-                      <a:srgbClr val="1A222C"/>
-                    </a:solidFill>
-                  </a:tcPr>
-                </a:tc>
-                <a:tc>
-                  <a:txBody>
-                    <a:bodyPr/>
-                    <a:lstStyle/>
-                    <a:p>
-                      <a:pPr algn="ctr"/>
-                      <a:r>
-                        <a:rPr sz="1400" b="0">
-                          <a:solidFill>
-                            <a:srgbClr val="E8EDF2"/>
-                          </a:solidFill>
-                          <a:latin typeface="Segoe UI"/>
-                        </a:rPr>
-                        <a:t>-</a:t>
-                      </a:r>
-                    </a:p>
-                  </a:txBody>
-                  <a:tcPr marL="45720" marR="45720" marT="27432" marB="27432">
-                    <a:solidFill>
-                      <a:srgbClr val="1A222C"/>
-                    </a:solidFill>
-                  </a:tcPr>
-                </a:tc>
-                <a:tc>
-                  <a:txBody>
-                    <a:bodyPr/>
-                    <a:lstStyle/>
-                    <a:p>
-                      <a:pPr algn="ctr"/>
-                      <a:r>
-                        <a:rPr sz="1400" b="0">
-                          <a:solidFill>
-                            <a:srgbClr val="E8EDF2"/>
-                          </a:solidFill>
-                          <a:latin typeface="Segoe UI"/>
-                        </a:rPr>
-                        <a:t>-</a:t>
-                      </a:r>
-                    </a:p>
-                  </a:txBody>
-                  <a:tcPr marL="45720" marR="45720" marT="27432" marB="27432">
-                    <a:solidFill>
-                      <a:srgbClr val="1A222C"/>
-                    </a:solidFill>
-                  </a:tcPr>
-                </a:tc>
-                <a:tc>
-                  <a:txBody>
-                    <a:bodyPr/>
-                    <a:lstStyle/>
-                    <a:p>
-                      <a:pPr algn="ctr"/>
-                      <a:r>
-                        <a:rPr sz="1400" b="0">
-                          <a:solidFill>
-                            <a:srgbClr val="E8EDF2"/>
-                          </a:solidFill>
-                          <a:latin typeface="Segoe UI"/>
-                        </a:rPr>
-                        <a:t>-</a:t>
-                      </a:r>
-                    </a:p>
-                  </a:txBody>
-                  <a:tcPr marL="45720" marR="45720" marT="27432" marB="27432">
-                    <a:solidFill>
-                      <a:srgbClr val="1A222C"/>
-                    </a:solidFill>
-                  </a:tcPr>
-                </a:tc>
-                <a:tc>
-                  <a:txBody>
-                    <a:bodyPr/>
-                    <a:lstStyle/>
-                    <a:p>
-                      <a:pPr algn="ctr"/>
-                      <a:r>
-                        <a:rPr sz="1400" b="0">
-                          <a:solidFill>
-                            <a:srgbClr val="E8EDF2"/>
-                          </a:solidFill>
-                          <a:latin typeface="Segoe UI"/>
-                        </a:rPr>
-                        <a:t>-</a:t>
-                      </a:r>
-                    </a:p>
-                  </a:txBody>
-                  <a:tcPr marL="45720" marR="45720" marT="27432" marB="27432">
-                    <a:solidFill>
-                      <a:srgbClr val="1A222C"/>
-                    </a:solidFill>
-                  </a:tcPr>
-                </a:tc>
-                <a:tc>
-                  <a:txBody>
-                    <a:bodyPr/>
-                    <a:lstStyle/>
-                    <a:p>
-                      <a:pPr algn="ctr"/>
-                      <a:r>
-                        <a:rPr sz="1400" b="0">
-                          <a:solidFill>
-                            <a:srgbClr val="E8EDF2"/>
-                          </a:solidFill>
-                          <a:latin typeface="Segoe UI"/>
-                        </a:rPr>
-                        <a:t>-</a:t>
-                      </a:r>
-                    </a:p>
-                  </a:txBody>
-                  <a:tcPr marL="45720" marR="45720" marT="27432" marB="27432">
-                    <a:solidFill>
-                      <a:srgbClr val="1A222C"/>
-                    </a:solidFill>
-                  </a:tcPr>
-                </a:tc>
-                <a:tc>
-                  <a:txBody>
-                    <a:bodyPr/>
-                    <a:lstStyle/>
-                    <a:p>
-                      <a:pPr algn="ctr"/>
-                      <a:r>
-                        <a:rPr sz="1400" b="0">
-                          <a:solidFill>
-                            <a:srgbClr val="E8EDF2"/>
-                          </a:solidFill>
-                          <a:latin typeface="Segoe UI"/>
-                        </a:rPr>
-                        <a:t>-</a:t>
-                      </a:r>
-                    </a:p>
-                  </a:txBody>
-                  <a:tcPr marL="45720" marR="45720" marT="27432" marB="27432">
-                    <a:solidFill>
-                      <a:srgbClr val="1A222C"/>
-                    </a:solidFill>
-                  </a:tcPr>
-                </a:tc>
-                <a:tc>
-                  <a:txBody>
-                    <a:bodyPr/>
-                    <a:lstStyle/>
-                    <a:p>
-                      <a:pPr algn="ctr"/>
-                      <a:r>
-                        <a:rPr sz="1400" b="0">
-                          <a:solidFill>
-                            <a:srgbClr val="E8EDF2"/>
-                          </a:solidFill>
-                          <a:latin typeface="Segoe UI"/>
-                        </a:rPr>
-                        <a:t>-</a:t>
                       </a:r>
                     </a:p>
                   </a:txBody>

</xml_diff>

<commit_message>
deliverables: mark per-workload overhead validity (baseline<=streaming) honestly
Subtitles now state which overheads are real vs below-noise:
- io_bench (C): small but consistent +1.1..1.3s (~0.2%), 3/3 reps valid.
- python-ml: large reproducible +137..140s (+66%), 3/3 reps valid.
- io_bench_py: overhead below run-to-run noise (~0); reps 2-3 land under baseline.
- mpi (paced): overhead below noise (~0); single rep -1.7s.
- dlio: wall cold/warm-dominated -> per-event is the metric.
</commit_message>
<xml_diff>
--- a/deliverables/paper_overhead_tables.pptx
+++ b/deliverables/paper_overhead_tables.pptx
@@ -3262,7 +3262,7 @@
                 </a:solidFill>
                 <a:latin typeface="Segoe UI"/>
               </a:rPr>
-              <a:t>Overlap-friendly POSIX write/read + sleep. Fidelity EXACT. walltime = WORK region.</a:t>
+              <a:t>Overlap-friendly. Fidelity EXACT. Overhead small but CONSISTENT across 3 reps (+1.1 to +1.3 s, ~0.2%).</a:t>
             </a:r>
           </a:p>
         </p:txBody>
@@ -4355,7 +4355,7 @@
                 </a:solidFill>
                 <a:latin typeface="Segoe UI"/>
               </a:rPr>
-              <a:t>Overlap-friendly POSIX write/read + sleep. Fidelity EXACT. walltime = WORK region.</a:t>
+              <a:t>Overlap-friendly. Fidelity EXACT. Overhead is BELOW run-to-run noise (~0): reps 2-3 land slightly under baseline (-1.6, -2.1 s) -- i.e. streaming is effectively free here.</a:t>
             </a:r>
           </a:p>
         </p:txBody>
@@ -5448,7 +5448,7 @@
                 </a:solidFill>
                 <a:latin typeface="Segoe UI"/>
               </a:rPr>
-              <a:t>NumPy/PyTorch, compute-bound. Fidelity EXACT. walltime = WORK region.</a:t>
+              <a:t>NumPy/PyTorch, compute-bound. Fidelity EXACT. LARGE, reproducible overhead: +137 to +140 s (+66%) across 3 reps.</a:t>
             </a:r>
           </a:p>
         </p:txBody>
@@ -6541,7 +6541,7 @@
                 </a:solidFill>
                 <a:latin typeface="Segoe UI"/>
               </a:rPr>
-              <a:t>MPI unsupported over CXI. Paced (IO_SLEEP_MS) for a comparable ~600 s wall. Fidelity EXACT (32-&gt;1 aggregated).</a:t>
+              <a:t>MPI unsupported over CXI. Paced (~600 s wall). Fidelity EXACT (32-&gt;1). Overhead below noise (~0): the one rep lands -1.7 s vs baseline -- streaming effectively free on this I/O-bound run.</a:t>
             </a:r>
           </a:p>
         </p:txBody>

</xml_diff>

<commit_message>
ALCF Polaris: state-B connector (counters[] at close, no rec_hex), fclose in io_bench for STDIO, margo basic_wait fix in overhead runner, io_bench realistic C workload, overhead_study consolidation, deliverables
Submodule pins: darshan b9deb880 (mofka-dev state B), diaspora c146e07 (RawSerializer).
</commit_message>
<xml_diff>
--- a/deliverables/paper_overhead_tables.pptx
+++ b/deliverables/paper_overhead_tables.pptx
@@ -7262,7 +7262,7 @@
                 </a:solidFill>
                 <a:latin typeface="Segoe UI"/>
               </a:rPr>
-              <a:t>TensorFlow NPZ data-gen. Fidelity EXACT (32-&gt;1 aggregated). Wall = cold/warm-dominated -&gt; per-event cost is the metric.</a:t>
+              <a:t>TensorFlow NPZ data-gen. Fidelity EXACT (32-&gt;1). Wall = COLD-vs-WARM: baseline ran cold (TF import + FS warmup ~139 s); streaming reps ran warm (~15 s) -&gt; wall not comparable, per-event is the metric.</a:t>
             </a:r>
           </a:p>
         </p:txBody>
@@ -7277,7 +7277,7 @@
         </p:nvGraphicFramePr>
         <p:xfrm>
           <a:off x="365760" y="2011680"/>
-          <a:ext cx="11429999" cy="2560320"/>
+          <a:ext cx="11429999" cy="3200400"/>
         </p:xfrm>
         <a:graphic>
           <a:graphicData uri="http://schemas.openxmlformats.org/drawingml/2006/table">
@@ -7489,32 +7489,55 @@
                     <a:p>
                       <a:pPr algn="l"/>
                       <a:r>
-                        <a:rPr sz="1400" b="1">
+                        <a:rPr sz="1400" b="0">
                           <a:solidFill>
                             <a:srgbClr val="4FC3F7"/>
                           </a:solidFill>
                           <a:latin typeface="Segoe UI"/>
                         </a:rPr>
-                        <a:t>baseline</a:t>
-                      </a:r>
-                    </a:p>
-                  </a:txBody>
-                  <a:tcPr marL="45720" marR="45720" marT="27432" marB="27432">
-                    <a:solidFill>
-                      <a:srgbClr val="12202B"/>
-                    </a:solidFill>
-                  </a:tcPr>
-                </a:tc>
-                <a:tc>
-                  <a:txBody>
-                    <a:bodyPr/>
-                    <a:lstStyle/>
-                    <a:p>
-                      <a:pPr algn="ctr"/>
-                      <a:r>
-                        <a:rPr sz="1400" b="1">
-                          <a:solidFill>
-                            <a:srgbClr val="FFFFFF"/>
+                        <a:t>baseline (cold)</a:t>
+                      </a:r>
+                    </a:p>
+                  </a:txBody>
+                  <a:tcPr marL="45720" marR="45720" marT="27432" marB="27432">
+                    <a:solidFill>
+                      <a:srgbClr val="1A222C"/>
+                    </a:solidFill>
+                  </a:tcPr>
+                </a:tc>
+                <a:tc>
+                  <a:txBody>
+                    <a:bodyPr/>
+                    <a:lstStyle/>
+                    <a:p>
+                      <a:pPr algn="ctr"/>
+                      <a:r>
+                        <a:rPr sz="1400" b="0">
+                          <a:solidFill>
+                            <a:srgbClr val="E8EDF2"/>
+                          </a:solidFill>
+                          <a:latin typeface="Segoe UI"/>
+                        </a:rPr>
+                        <a:t>475,994</a:t>
+                      </a:r>
+                    </a:p>
+                  </a:txBody>
+                  <a:tcPr marL="45720" marR="45720" marT="27432" marB="27432">
+                    <a:solidFill>
+                      <a:srgbClr val="1A222C"/>
+                    </a:solidFill>
+                  </a:tcPr>
+                </a:tc>
+                <a:tc>
+                  <a:txBody>
+                    <a:bodyPr/>
+                    <a:lstStyle/>
+                    <a:p>
+                      <a:pPr algn="ctr"/>
+                      <a:r>
+                        <a:rPr sz="1400" b="0">
+                          <a:solidFill>
+                            <a:srgbClr val="E8EDF2"/>
                           </a:solidFill>
                           <a:latin typeface="Segoe UI"/>
                         </a:rPr>
@@ -7524,20 +7547,20 @@
                   </a:txBody>
                   <a:tcPr marL="45720" marR="45720" marT="27432" marB="27432">
                     <a:solidFill>
-                      <a:srgbClr val="12202B"/>
-                    </a:solidFill>
-                  </a:tcPr>
-                </a:tc>
-                <a:tc>
-                  <a:txBody>
-                    <a:bodyPr/>
-                    <a:lstStyle/>
-                    <a:p>
-                      <a:pPr algn="ctr"/>
-                      <a:r>
-                        <a:rPr sz="1400" b="1">
-                          <a:solidFill>
-                            <a:srgbClr val="FFFFFF"/>
+                      <a:srgbClr val="1A222C"/>
+                    </a:solidFill>
+                  </a:tcPr>
+                </a:tc>
+                <a:tc>
+                  <a:txBody>
+                    <a:bodyPr/>
+                    <a:lstStyle/>
+                    <a:p>
+                      <a:pPr algn="ctr"/>
+                      <a:r>
+                        <a:rPr sz="1400" b="0">
+                          <a:solidFill>
+                            <a:srgbClr val="E8EDF2"/>
                           </a:solidFill>
                           <a:latin typeface="Segoe UI"/>
                         </a:rPr>
@@ -7547,20 +7570,20 @@
                   </a:txBody>
                   <a:tcPr marL="45720" marR="45720" marT="27432" marB="27432">
                     <a:solidFill>
-                      <a:srgbClr val="12202B"/>
-                    </a:solidFill>
-                  </a:tcPr>
-                </a:tc>
-                <a:tc>
-                  <a:txBody>
-                    <a:bodyPr/>
-                    <a:lstStyle/>
-                    <a:p>
-                      <a:pPr algn="ctr"/>
-                      <a:r>
-                        <a:rPr sz="1400" b="1">
-                          <a:solidFill>
-                            <a:srgbClr val="FFFFFF"/>
+                      <a:srgbClr val="1A222C"/>
+                    </a:solidFill>
+                  </a:tcPr>
+                </a:tc>
+                <a:tc>
+                  <a:txBody>
+                    <a:bodyPr/>
+                    <a:lstStyle/>
+                    <a:p>
+                      <a:pPr algn="ctr"/>
+                      <a:r>
+                        <a:rPr sz="1400" b="0">
+                          <a:solidFill>
+                            <a:srgbClr val="E8EDF2"/>
                           </a:solidFill>
                           <a:latin typeface="Segoe UI"/>
                         </a:rPr>
@@ -7570,20 +7593,20 @@
                   </a:txBody>
                   <a:tcPr marL="45720" marR="45720" marT="27432" marB="27432">
                     <a:solidFill>
-                      <a:srgbClr val="12202B"/>
-                    </a:solidFill>
-                  </a:tcPr>
-                </a:tc>
-                <a:tc>
-                  <a:txBody>
-                    <a:bodyPr/>
-                    <a:lstStyle/>
-                    <a:p>
-                      <a:pPr algn="ctr"/>
-                      <a:r>
-                        <a:rPr sz="1400" b="1">
-                          <a:solidFill>
-                            <a:srgbClr val="FFFFFF"/>
+                      <a:srgbClr val="1A222C"/>
+                    </a:solidFill>
+                  </a:tcPr>
+                </a:tc>
+                <a:tc>
+                  <a:txBody>
+                    <a:bodyPr/>
+                    <a:lstStyle/>
+                    <a:p>
+                      <a:pPr algn="ctr"/>
+                      <a:r>
+                        <a:rPr sz="1400" b="0">
+                          <a:solidFill>
+                            <a:srgbClr val="E8EDF2"/>
                           </a:solidFill>
                           <a:latin typeface="Segoe UI"/>
                         </a:rPr>
@@ -7593,76 +7616,53 @@
                   </a:txBody>
                   <a:tcPr marL="45720" marR="45720" marT="27432" marB="27432">
                     <a:solidFill>
-                      <a:srgbClr val="12202B"/>
-                    </a:solidFill>
-                  </a:tcPr>
-                </a:tc>
-                <a:tc>
-                  <a:txBody>
-                    <a:bodyPr/>
-                    <a:lstStyle/>
-                    <a:p>
-                      <a:pPr algn="ctr"/>
-                      <a:r>
-                        <a:rPr sz="1400" b="1">
-                          <a:solidFill>
-                            <a:srgbClr val="FFFFFF"/>
-                          </a:solidFill>
-                          <a:latin typeface="Segoe UI"/>
-                        </a:rPr>
-                        <a:t>-</a:t>
-                      </a:r>
-                    </a:p>
-                  </a:txBody>
-                  <a:tcPr marL="45720" marR="45720" marT="27432" marB="27432">
-                    <a:solidFill>
-                      <a:srgbClr val="12202B"/>
-                    </a:solidFill>
-                  </a:tcPr>
-                </a:tc>
-                <a:tc>
-                  <a:txBody>
-                    <a:bodyPr/>
-                    <a:lstStyle/>
-                    <a:p>
-                      <a:pPr algn="ctr"/>
-                      <a:r>
-                        <a:rPr sz="1400" b="1">
-                          <a:solidFill>
-                            <a:srgbClr val="FFFFFF"/>
-                          </a:solidFill>
-                          <a:latin typeface="Segoe UI"/>
-                        </a:rPr>
-                        <a:t>n/a</a:t>
-                      </a:r>
-                    </a:p>
-                  </a:txBody>
-                  <a:tcPr marL="45720" marR="45720" marT="27432" marB="27432">
-                    <a:solidFill>
-                      <a:srgbClr val="12202B"/>
-                    </a:solidFill>
-                  </a:tcPr>
-                </a:tc>
-                <a:tc>
-                  <a:txBody>
-                    <a:bodyPr/>
-                    <a:lstStyle/>
-                    <a:p>
-                      <a:pPr algn="ctr"/>
-                      <a:r>
-                        <a:rPr sz="1400" b="1">
-                          <a:solidFill>
-                            <a:srgbClr val="FFFFFF"/>
-                          </a:solidFill>
-                          <a:latin typeface="Segoe UI"/>
-                        </a:rPr>
-                        <a:t>n/a</a:t>
-                      </a:r>
-                    </a:p>
-                  </a:txBody>
-                  <a:tcPr marL="45720" marR="45720" marT="27432" marB="27432">
-                    <a:solidFill>
-                      <a:srgbClr val="12202B"/>
+                      <a:srgbClr val="1A222C"/>
+                    </a:solidFill>
+                  </a:tcPr>
+                </a:tc>
+                <a:tc>
+                  <a:txBody>
+                    <a:bodyPr/>
+                    <a:lstStyle/>
+                    <a:p>
+                      <a:pPr algn="ctr"/>
+                      <a:r>
+                        <a:rPr sz="1400" b="0">
+                          <a:solidFill>
+                            <a:srgbClr val="E8EDF2"/>
+                          </a:solidFill>
+                          <a:latin typeface="Segoe UI"/>
+                        </a:rPr>
+                        <a:t>139.2</a:t>
+                      </a:r>
+                    </a:p>
+                  </a:txBody>
+                  <a:tcPr marL="45720" marR="45720" marT="27432" marB="27432">
+                    <a:solidFill>
+                      <a:srgbClr val="1A222C"/>
+                    </a:solidFill>
+                  </a:tcPr>
+                </a:tc>
+                <a:tc>
+                  <a:txBody>
+                    <a:bodyPr/>
+                    <a:lstStyle/>
+                    <a:p>
+                      <a:pPr algn="ctr"/>
+                      <a:r>
+                        <a:rPr sz="1400" b="0">
+                          <a:solidFill>
+                            <a:srgbClr val="E8EDF2"/>
+                          </a:solidFill>
+                          <a:latin typeface="Segoe UI"/>
+                        </a:rPr>
+                        <a:t>0.0</a:t>
+                      </a:r>
+                    </a:p>
+                  </a:txBody>
+                  <a:tcPr marL="45720" marR="45720" marT="27432" marB="27432">
+                    <a:solidFill>
+                      <a:srgbClr val="1A222C"/>
                     </a:solidFill>
                   </a:tcPr>
                 </a:tc>
@@ -7681,7 +7681,7 @@
                           </a:solidFill>
                           <a:latin typeface="Segoe UI"/>
                         </a:rPr>
-                        <a:t>streaming r1</a:t>
+                        <a:t>streaming r1 (warm)</a:t>
                       </a:r>
                     </a:p>
                   </a:txBody>
@@ -7819,30 +7819,30 @@
                           </a:solidFill>
                           <a:latin typeface="Segoe UI"/>
                         </a:rPr>
-                        <a:t>n/a</a:t>
-                      </a:r>
-                    </a:p>
-                  </a:txBody>
-                  <a:tcPr marL="45720" marR="45720" marT="27432" marB="27432">
-                    <a:solidFill>
-                      <a:srgbClr val="1A222C"/>
-                    </a:solidFill>
-                  </a:tcPr>
-                </a:tc>
-                <a:tc>
-                  <a:txBody>
-                    <a:bodyPr/>
-                    <a:lstStyle/>
-                    <a:p>
-                      <a:pPr algn="ctr"/>
-                      <a:r>
-                        <a:rPr sz="1400" b="0">
-                          <a:solidFill>
-                            <a:srgbClr val="E8EDF2"/>
-                          </a:solidFill>
-                          <a:latin typeface="Segoe UI"/>
-                        </a:rPr>
-                        <a:t>n/a</a:t>
+                        <a:t>15.0</a:t>
+                      </a:r>
+                    </a:p>
+                  </a:txBody>
+                  <a:tcPr marL="45720" marR="45720" marT="27432" marB="27432">
+                    <a:solidFill>
+                      <a:srgbClr val="1A222C"/>
+                    </a:solidFill>
+                  </a:tcPr>
+                </a:tc>
+                <a:tc>
+                  <a:txBody>
+                    <a:bodyPr/>
+                    <a:lstStyle/>
+                    <a:p>
+                      <a:pPr algn="ctr"/>
+                      <a:r>
+                        <a:rPr sz="1400" b="0">
+                          <a:solidFill>
+                            <a:srgbClr val="E8EDF2"/>
+                          </a:solidFill>
+                          <a:latin typeface="Segoe UI"/>
+                        </a:rPr>
+                        <a:t>-124</a:t>
                       </a:r>
                     </a:p>
                   </a:txBody>
@@ -7867,7 +7867,7 @@
                           </a:solidFill>
                           <a:latin typeface="Segoe UI"/>
                         </a:rPr>
-                        <a:t>streaming r2</a:t>
+                        <a:t>streaming r2 (warm)</a:t>
                       </a:r>
                     </a:p>
                   </a:txBody>
@@ -8005,30 +8005,216 @@
                           </a:solidFill>
                           <a:latin typeface="Segoe UI"/>
                         </a:rPr>
-                        <a:t>n/a</a:t>
-                      </a:r>
-                    </a:p>
-                  </a:txBody>
-                  <a:tcPr marL="45720" marR="45720" marT="27432" marB="27432">
-                    <a:solidFill>
-                      <a:srgbClr val="1A222C"/>
-                    </a:solidFill>
-                  </a:tcPr>
-                </a:tc>
-                <a:tc>
-                  <a:txBody>
-                    <a:bodyPr/>
-                    <a:lstStyle/>
-                    <a:p>
-                      <a:pPr algn="ctr"/>
-                      <a:r>
-                        <a:rPr sz="1400" b="0">
-                          <a:solidFill>
-                            <a:srgbClr val="E8EDF2"/>
-                          </a:solidFill>
-                          <a:latin typeface="Segoe UI"/>
-                        </a:rPr>
-                        <a:t>n/a</a:t>
+                        <a:t>48.3</a:t>
+                      </a:r>
+                    </a:p>
+                  </a:txBody>
+                  <a:tcPr marL="45720" marR="45720" marT="27432" marB="27432">
+                    <a:solidFill>
+                      <a:srgbClr val="1A222C"/>
+                    </a:solidFill>
+                  </a:tcPr>
+                </a:tc>
+                <a:tc>
+                  <a:txBody>
+                    <a:bodyPr/>
+                    <a:lstStyle/>
+                    <a:p>
+                      <a:pPr algn="ctr"/>
+                      <a:r>
+                        <a:rPr sz="1400" b="0">
+                          <a:solidFill>
+                            <a:srgbClr val="E8EDF2"/>
+                          </a:solidFill>
+                          <a:latin typeface="Segoe UI"/>
+                        </a:rPr>
+                        <a:t>-91</a:t>
+                      </a:r>
+                    </a:p>
+                  </a:txBody>
+                  <a:tcPr marL="45720" marR="45720" marT="27432" marB="27432">
+                    <a:solidFill>
+                      <a:srgbClr val="1A222C"/>
+                    </a:solidFill>
+                  </a:tcPr>
+                </a:tc>
+              </a:tr>
+              <a:tr h="640080">
+                <a:tc>
+                  <a:txBody>
+                    <a:bodyPr/>
+                    <a:lstStyle/>
+                    <a:p>
+                      <a:pPr algn="l"/>
+                      <a:r>
+                        <a:rPr sz="1400" b="0">
+                          <a:solidFill>
+                            <a:srgbClr val="4FC3F7"/>
+                          </a:solidFill>
+                          <a:latin typeface="Segoe UI"/>
+                        </a:rPr>
+                        <a:t>streaming r3 (warm)</a:t>
+                      </a:r>
+                    </a:p>
+                  </a:txBody>
+                  <a:tcPr marL="45720" marR="45720" marT="27432" marB="27432">
+                    <a:solidFill>
+                      <a:srgbClr val="1A222C"/>
+                    </a:solidFill>
+                  </a:tcPr>
+                </a:tc>
+                <a:tc>
+                  <a:txBody>
+                    <a:bodyPr/>
+                    <a:lstStyle/>
+                    <a:p>
+                      <a:pPr algn="ctr"/>
+                      <a:r>
+                        <a:rPr sz="1400" b="0">
+                          <a:solidFill>
+                            <a:srgbClr val="E8EDF2"/>
+                          </a:solidFill>
+                          <a:latin typeface="Segoe UI"/>
+                        </a:rPr>
+                        <a:t>475,994</a:t>
+                      </a:r>
+                    </a:p>
+                  </a:txBody>
+                  <a:tcPr marL="45720" marR="45720" marT="27432" marB="27432">
+                    <a:solidFill>
+                      <a:srgbClr val="1A222C"/>
+                    </a:solidFill>
+                  </a:tcPr>
+                </a:tc>
+                <a:tc>
+                  <a:txBody>
+                    <a:bodyPr/>
+                    <a:lstStyle/>
+                    <a:p>
+                      <a:pPr algn="ctr"/>
+                      <a:r>
+                        <a:rPr sz="1400" b="0">
+                          <a:solidFill>
+                            <a:srgbClr val="E8EDF2"/>
+                          </a:solidFill>
+                          <a:latin typeface="Segoe UI"/>
+                        </a:rPr>
+                        <a:t>3.0</a:t>
+                      </a:r>
+                    </a:p>
+                  </a:txBody>
+                  <a:tcPr marL="45720" marR="45720" marT="27432" marB="27432">
+                    <a:solidFill>
+                      <a:srgbClr val="1A222C"/>
+                    </a:solidFill>
+                  </a:tcPr>
+                </a:tc>
+                <a:tc>
+                  <a:txBody>
+                    <a:bodyPr/>
+                    <a:lstStyle/>
+                    <a:p>
+                      <a:pPr algn="ctr"/>
+                      <a:r>
+                        <a:rPr sz="1400" b="0">
+                          <a:solidFill>
+                            <a:srgbClr val="E8EDF2"/>
+                          </a:solidFill>
+                          <a:latin typeface="Segoe UI"/>
+                        </a:rPr>
+                        <a:t>38.0</a:t>
+                      </a:r>
+                    </a:p>
+                  </a:txBody>
+                  <a:tcPr marL="45720" marR="45720" marT="27432" marB="27432">
+                    <a:solidFill>
+                      <a:srgbClr val="1A222C"/>
+                    </a:solidFill>
+                  </a:tcPr>
+                </a:tc>
+                <a:tc>
+                  <a:txBody>
+                    <a:bodyPr/>
+                    <a:lstStyle/>
+                    <a:p>
+                      <a:pPr algn="ctr"/>
+                      <a:r>
+                        <a:rPr sz="1400" b="0">
+                          <a:solidFill>
+                            <a:srgbClr val="E8EDF2"/>
+                          </a:solidFill>
+                          <a:latin typeface="Segoe UI"/>
+                        </a:rPr>
+                        <a:t>3.25</a:t>
+                      </a:r>
+                    </a:p>
+                  </a:txBody>
+                  <a:tcPr marL="45720" marR="45720" marT="27432" marB="27432">
+                    <a:solidFill>
+                      <a:srgbClr val="1A222C"/>
+                    </a:solidFill>
+                  </a:tcPr>
+                </a:tc>
+                <a:tc>
+                  <a:txBody>
+                    <a:bodyPr/>
+                    <a:lstStyle/>
+                    <a:p>
+                      <a:pPr algn="ctr"/>
+                      <a:r>
+                        <a:rPr sz="1400" b="0">
+                          <a:solidFill>
+                            <a:srgbClr val="E8EDF2"/>
+                          </a:solidFill>
+                          <a:latin typeface="Segoe UI"/>
+                        </a:rPr>
+                        <a:t>0.004</a:t>
+                      </a:r>
+                    </a:p>
+                  </a:txBody>
+                  <a:tcPr marL="45720" marR="45720" marT="27432" marB="27432">
+                    <a:solidFill>
+                      <a:srgbClr val="1A222C"/>
+                    </a:solidFill>
+                  </a:tcPr>
+                </a:tc>
+                <a:tc>
+                  <a:txBody>
+                    <a:bodyPr/>
+                    <a:lstStyle/>
+                    <a:p>
+                      <a:pPr algn="ctr"/>
+                      <a:r>
+                        <a:rPr sz="1400" b="0">
+                          <a:solidFill>
+                            <a:srgbClr val="E8EDF2"/>
+                          </a:solidFill>
+                          <a:latin typeface="Segoe UI"/>
+                        </a:rPr>
+                        <a:t>15.3</a:t>
+                      </a:r>
+                    </a:p>
+                  </a:txBody>
+                  <a:tcPr marL="45720" marR="45720" marT="27432" marB="27432">
+                    <a:solidFill>
+                      <a:srgbClr val="1A222C"/>
+                    </a:solidFill>
+                  </a:tcPr>
+                </a:tc>
+                <a:tc>
+                  <a:txBody>
+                    <a:bodyPr/>
+                    <a:lstStyle/>
+                    <a:p>
+                      <a:pPr algn="ctr"/>
+                      <a:r>
+                        <a:rPr sz="1400" b="0">
+                          <a:solidFill>
+                            <a:srgbClr val="E8EDF2"/>
+                          </a:solidFill>
+                          <a:latin typeface="Segoe UI"/>
+                        </a:rPr>
+                        <a:t>-124</a:t>
                       </a:r>
                     </a:p>
                   </a:txBody>

</xml_diff>